<commit_message>
v2.43: the Tell step (P13) clarified from the Evening 6 debrief (John's word, 2026-10-27) - beat 1 "Re-form pairs out of pairs" (a CCA cluster leftover) becomes "stay in the pair you worked in"; slide reads "Still in your family pair"; a short-clock line; what happened on 26 October added to the Evening 6 notes; Session 7 spare matches; leader notes rebuilt from the decks; synced to OneDrive; search index rebuilt
Co-Authored-By: Claude Opus 5.5 <noreply@anthropic.com>
</commit_message>
<xml_diff>
--- a/_implementation-notes/evening-series/FotH Evening Session 7 Slides DRAFT v1.pptx
+++ b/_implementation-notes/evening-series/FotH Evening Session 7 Slides DRAFT v1.pptx
@@ -1619,13 +1619,19 @@
           <a:p>
             <a:r>
               <a:rPr lang="en-US" sz="1200"/>
-              <a:t>BEATS: 1. Re-form pairs out of pairs. 2. Each person tells ONE specific thing they heard today — one sentence, witnessed. 3. Receive each with 'We hear that' or 'Thank you for naming that' — no preaching, no interpreting. 4. Close the pair: what we heard is given to be walked out this week.</a:t>
+              <a:t>BEATS: 1. Stay in the pair you worked in: the Tell happens where you heard, before anyone moves. 2. Each person tells ONE specific thing they heard today — one sentence, witnessed. 3. Receive each with 'We hear that' or 'Thank you for naming that' — no preaching, no interpreting. 4. Close the pair: what we heard is given to be walked out this week.</a:t>
             </a:r>
           </a:p>
           <a:p>
             <a:r>
               <a:rPr lang="en-US" sz="1200"/>
               <a:t>CUES: Arranged parent opens the round (check the Run Card) — never cold-call a teen; teens choose their own depth; pass-anytime holds.</a:t>
+            </a:r>
+          </a:p>
+          <a:p>
+            <a:r>
+              <a:rPr lang="en-US" sz="1200"/>
+              <a:t>IF TIME RAN SHORT: If only one of you walked the six steps, that one still tells. The Listener tells one thing they noticed while listening.</a:t>
             </a:r>
           </a:p>
         </p:txBody>
@@ -6044,7 +6050,7 @@
                 </a:solidFill>
                 <a:latin typeface="Calibri"/>
               </a:rPr>
-              <a:t>Back in the family pair — each of us tells ONE specific thing we heard tonight</a:t>
+              <a:t>Still in your family pair — each of us tells ONE specific thing we heard tonight</a:t>
             </a:r>
           </a:p>
           <a:p>

</xml_diff>

<commit_message>
v2.44: the merge (P14) invites each person to say briefly what they heard (John's word, 2026-10-27, from the Evening 6 debrief); the Tell gives three minutes to the merge (Tell 8:13-8:16, merge 8:16-8:20); decks, leader notes, both run sheets, Pair Card and the Evening 6 page updated; Session 7 spare matches; P13 lines tightened to keep the notes on four pages; synced to OneDrive; search index rebuilt
Co-Authored-By: Claude Opus 5.5 <noreply@anthropic.com>
</commit_message>
<xml_diff>
--- a/_implementation-notes/evening-series/FotH Evening Session 7 Slides DRAFT v1.pptx
+++ b/_implementation-notes/evening-series/FotH Evening Session 7 Slides DRAFT v1.pptx
@@ -1613,7 +1613,7 @@
           <a:p>
             <a:r>
               <a:rPr lang="en-US" sz="1200"/>
-              <a:t>S7 · 8:13–8:19 · LEAD: CONTENT PRESENTER · PAIRS</a:t>
+              <a:t>S7 · 8:13–8:16 · LEAD: CONTENT PRESENTER · PAIRS</a:t>
             </a:r>
           </a:p>
           <a:p>
@@ -1631,7 +1631,7 @@
           <a:p>
             <a:r>
               <a:rPr lang="en-US" sz="1200"/>
-              <a:t>IF TIME RAN SHORT: If only one of you walked the six steps, that one still tells. The Listener tells one thing they noticed while listening.</a:t>
+              <a:t>IF TIME RAN SHORT: If only one of you walked the steps, that one tells; the Listener tells what they noticed.</a:t>
             </a:r>
           </a:p>
         </p:txBody>
@@ -1678,19 +1678,19 @@
           <a:p>
             <a:r>
               <a:rPr lang="en-US" sz="1200"/>
-              <a:t>S7 · 8:19–8:20 · LEAD: CONTAINER HOLDER</a:t>
+              <a:t>S7 · 8:16–8:20 · LEAD: CONTAINER HOLDER</a:t>
             </a:r>
           </a:p>
           <a:p>
             <a:r>
               <a:rPr lang="en-US" sz="1200"/>
-              <a:t>BEATS: 1. One word each — not what you heard (that is yours), but what the practice was like. 2. Introduce daily PROAPT: one short passage, five to ten minutes, every day — the journal Week 7 pages have the template. 3. Hold up H7.3: passage paths for teens and parents. 4. 'The chain only works if we work it.'</a:t>
+              <a:t>BEATS: 1. Each person says briefly what they heard tonight — the one sentence told in the pair. Receive it with 'We hear that'; no comment. On 26 October this was when the room came alive. 2. Introduce daily PROAPT: one short passage, five to ten minutes, every day — the journal Week 7 pages have the template. 3. Hold up H7.3: passage paths for teens and parents. 4. 'The chain only works if we work it.'</a:t>
             </a:r>
           </a:p>
           <a:p>
             <a:r>
               <a:rPr lang="en-US" sz="1200"/>
-              <a:t>CUES: Arranged parent begins the word round; anyone may pass.</a:t>
+              <a:t>CUES: Arranged parent begins; anyone may pass; one sentence each.</a:t>
             </a:r>
           </a:p>
         </p:txBody>
@@ -6322,7 +6322,7 @@
                 </a:solidFill>
                 <a:latin typeface="Calibri"/>
               </a:rPr>
-              <a:t>One word each — not what you heard (that’s yours), but what tonight’s practice was like; a parent begins</a:t>
+              <a:t>Back in the circle — each of us says briefly what we heard tonight: one sentence; a parent begins; pass-anytime holds</a:t>
             </a:r>
           </a:p>
           <a:p>

</xml_diff>